<commit_message>
cache a progress report in dscheck.einfo before the PBS walltime; bump version to 3.0.12
A long -A 3 or -A 4 batch run was killed by PBS before start_actions()
reached its email block, so no report was ever sent. Rather than cut the
work short to make time for the mail, the run now parks a progress report
in dscheck.einfo an hour before the walltime and keeps going: the dscheck
daemon mails that report once the record is unlocked, and a run that does
finish overwrites it with the full report so only one mail goes out.

The walltime is read back from PBS (qstat ReqdTime) instead of assumed,
since the dscheck daemon caps the requested 24 hours to the maximum of
the queue the job lands in.

Co-Authored-By: Claude Opus 4.6 <noreply@anthropic.com>
</commit_message>
<xml_diff>
--- a/docs/slides/dsquasar_guide.pptx
+++ b/docs/slides/dsquasar_guide.pptx
@@ -16143,7 +16143,7 @@
                 <a:ea typeface="Poppins" pitchFamily="34" charset="-122"/>
                 <a:cs typeface="Poppins" pitchFamily="34" charset="-120"/>
               </a:rPr>
-              <a:t>The 23-hour walltime guard stops a long job cleanly and leaves its 'N' and 'T' records on file; the next run simply picks them up.</a:t>
+              <a:t>A job killed at the walltime leaves its 'N' and 'T' records on file and its progress report in dscheck.einfo; the next run simply picks them up.</a:t>
             </a:r>
             <a:endParaRPr lang="en-US" sz="1050" dirty="0"/>
           </a:p>
@@ -21893,7 +21893,7 @@
                 <a:ea typeface="Poppins" pitchFamily="34" charset="-122"/>
                 <a:cs typeface="Poppins" pitchFamily="34" charset="-120"/>
               </a:rPr>
-              <a:t>Stopping Cleanly Before PBS Kills the Job</a:t>
+              <a:t>Making Sure the Report Outlives the Job</a:t>
             </a:r>
             <a:endParaRPr lang="en-US" sz="3200" dirty="0"/>
           </a:p>
@@ -21935,7 +21935,7 @@
                 <a:ea typeface="Poppins" pitchFamily="34" charset="-122"/>
                 <a:cs typeface="Poppins" pitchFamily="34" charset="-120"/>
               </a:rPr>
-              <a:t>The queue gives the job 24 hours. A tar file killed halfway through leaves a partial file on disk and a bfile record that claims work is in progress. So dsquasar watches the clock itself.</a:t>
+              <a:t>The queue gives the job 24 hours, and a full pass over the archive can want more. Cutting the work short to make time for the mail wastes a whole run, so instead dsquasar parks a progress report in its dscheck record an hour before the limit, and keeps working.</a:t>
             </a:r>
             <a:endParaRPr lang="en-US" sz="1450" dirty="0"/>
           </a:p>
@@ -21955,262 +21955,6 @@
           <a:prstGeom prst="roundRect">
             <a:avLst>
               <a:gd name="adj" fmla="val 19048"/>
-            </a:avLst>
-          </a:prstGeom>
-          <a:solidFill>
-            <a:srgbClr val="0B2A63"/>
-          </a:solidFill>
-          <a:ln/>
-        </p:spPr>
-      </p:sp>
-      <p:sp>
-        <p:nvSpPr>
-          <p:cNvPr id="6" name="Shape 4"/>
-          <p:cNvSpPr/>
-          <p:nvPr/>
-        </p:nvSpPr>
-        <p:spPr>
-          <a:xfrm>
-            <a:off x="822960" y="2514600"/>
-            <a:ext cx="10077450" cy="384048"/>
-          </a:xfrm>
-          <a:prstGeom prst="roundRect">
-            <a:avLst>
-              <a:gd name="adj" fmla="val 19048"/>
-            </a:avLst>
-          </a:prstGeom>
-          <a:solidFill>
-            <a:srgbClr val="0057C2"/>
-          </a:solidFill>
-          <a:ln/>
-        </p:spPr>
-      </p:sp>
-      <p:sp>
-        <p:nvSpPr>
-          <p:cNvPr id="7" name="Text 5"/>
-          <p:cNvSpPr/>
-          <p:nvPr/>
-        </p:nvSpPr>
-        <p:spPr>
-          <a:xfrm>
-            <a:off x="822960" y="2514600"/>
-            <a:ext cx="10077450" cy="384048"/>
-          </a:xfrm>
-          <a:prstGeom prst="rect">
-            <a:avLst/>
-          </a:prstGeom>
-          <a:noFill/>
-          <a:ln/>
-        </p:spPr>
-        <p:txBody>
-          <a:bodyPr wrap="square" lIns="0" tIns="0" rIns="0" bIns="0" rtlCol="0" anchor="ctr"/>
-          <a:lstStyle/>
-          <a:p>
-            <a:pPr algn="ctr" indent="0" marL="0">
-              <a:buNone/>
-            </a:pPr>
-            <a:r>
-              <a:rPr lang="en-US" sz="1200" b="1" dirty="0">
-                <a:solidFill>
-                  <a:srgbClr val="FFFFFF"/>
-                </a:solidFill>
-                <a:latin typeface="Poppins" pitchFamily="34" charset="0"/>
-                <a:ea typeface="Poppins" pitchFamily="34" charset="-122"/>
-                <a:cs typeface="Poppins" pitchFamily="34" charset="-120"/>
-              </a:rPr>
-              <a:t>work accepted   —   0 h to 23 h</a:t>
-            </a:r>
-            <a:endParaRPr lang="en-US" sz="1200" dirty="0"/>
-          </a:p>
-        </p:txBody>
-      </p:sp>
-      <p:sp>
-        <p:nvSpPr>
-          <p:cNvPr id="8" name="Text 6"/>
-          <p:cNvSpPr/>
-          <p:nvPr/>
-        </p:nvSpPr>
-        <p:spPr>
-          <a:xfrm>
-            <a:off x="10900410" y="2496312"/>
-            <a:ext cx="438150" cy="420624"/>
-          </a:xfrm>
-          <a:prstGeom prst="rect">
-            <a:avLst/>
-          </a:prstGeom>
-          <a:noFill/>
-          <a:ln/>
-        </p:spPr>
-        <p:txBody>
-          <a:bodyPr wrap="square" lIns="0" tIns="0" rIns="0" bIns="0" rtlCol="0" anchor="ctr"/>
-          <a:lstStyle/>
-          <a:p>
-            <a:pPr algn="ctr" indent="0" marL="0">
-              <a:buNone/>
-            </a:pPr>
-            <a:r>
-              <a:rPr lang="en-US" sz="800" b="1" dirty="0">
-                <a:solidFill>
-                  <a:srgbClr val="42C0FF"/>
-                </a:solidFill>
-                <a:latin typeface="Poppins" pitchFamily="34" charset="0"/>
-                <a:ea typeface="Poppins" pitchFamily="34" charset="-122"/>
-                <a:cs typeface="Poppins" pitchFamily="34" charset="-120"/>
-              </a:rPr>
-              <a:t>wind</a:t>
-            </a:r>
-            <a:endParaRPr lang="en-US" sz="800" dirty="0"/>
-          </a:p>
-          <a:p>
-            <a:pPr algn="ctr" indent="0" marL="0">
-              <a:buNone/>
-            </a:pPr>
-            <a:r>
-              <a:rPr lang="en-US" sz="800" b="1" dirty="0">
-                <a:solidFill>
-                  <a:srgbClr val="42C0FF"/>
-                </a:solidFill>
-                <a:latin typeface="Poppins" pitchFamily="34" charset="0"/>
-                <a:ea typeface="Poppins" pitchFamily="34" charset="-122"/>
-                <a:cs typeface="Poppins" pitchFamily="34" charset="-120"/>
-              </a:rPr>
-              <a:t>down</a:t>
-            </a:r>
-            <a:endParaRPr lang="en-US" sz="800" dirty="0"/>
-          </a:p>
-        </p:txBody>
-      </p:sp>
-      <p:sp>
-        <p:nvSpPr>
-          <p:cNvPr id="9" name="Text 7"/>
-          <p:cNvSpPr/>
-          <p:nvPr/>
-        </p:nvSpPr>
-        <p:spPr>
-          <a:xfrm>
-            <a:off x="8705850" y="2185416"/>
-            <a:ext cx="2194560" cy="274320"/>
-          </a:xfrm>
-          <a:prstGeom prst="rect">
-            <a:avLst/>
-          </a:prstGeom>
-          <a:noFill/>
-          <a:ln/>
-        </p:spPr>
-        <p:txBody>
-          <a:bodyPr wrap="square" lIns="0" tIns="0" rIns="0" bIns="0" rtlCol="0" anchor="ctr"/>
-          <a:lstStyle/>
-          <a:p>
-            <a:pPr algn="r" indent="0" marL="0">
-              <a:buNone/>
-            </a:pPr>
-            <a:r>
-              <a:rPr lang="en-US" sz="1000" dirty="0">
-                <a:solidFill>
-                  <a:srgbClr val="42C0FF"/>
-                </a:solidFill>
-                <a:latin typeface="Courier New" pitchFamily="34" charset="0"/>
-                <a:ea typeface="Courier New" pitchFamily="34" charset="-122"/>
-                <a:cs typeface="Courier New" pitchFamily="34" charset="-120"/>
-              </a:rPr>
-              <a:t>MAXRUNTIME  23 h</a:t>
-            </a:r>
-            <a:endParaRPr lang="en-US" sz="1000" dirty="0"/>
-          </a:p>
-        </p:txBody>
-      </p:sp>
-      <p:sp>
-        <p:nvSpPr>
-          <p:cNvPr id="10" name="Text 8"/>
-          <p:cNvSpPr/>
-          <p:nvPr/>
-        </p:nvSpPr>
-        <p:spPr>
-          <a:xfrm>
-            <a:off x="822960" y="2971800"/>
-            <a:ext cx="1645920" cy="274320"/>
-          </a:xfrm>
-          <a:prstGeom prst="rect">
-            <a:avLst/>
-          </a:prstGeom>
-          <a:noFill/>
-          <a:ln/>
-        </p:spPr>
-        <p:txBody>
-          <a:bodyPr wrap="square" lIns="0" tIns="0" rIns="0" bIns="0" rtlCol="0" anchor="ctr"/>
-          <a:lstStyle/>
-          <a:p>
-            <a:pPr algn="l" indent="0" marL="0">
-              <a:buNone/>
-            </a:pPr>
-            <a:r>
-              <a:rPr lang="en-US" sz="1000" dirty="0">
-                <a:solidFill>
-                  <a:srgbClr val="97999B"/>
-                </a:solidFill>
-                <a:latin typeface="Courier New" pitchFamily="34" charset="0"/>
-                <a:ea typeface="Courier New" pitchFamily="34" charset="-122"/>
-                <a:cs typeface="Courier New" pitchFamily="34" charset="-120"/>
-              </a:rPr>
-              <a:t>0 h</a:t>
-            </a:r>
-            <a:endParaRPr lang="en-US" sz="1000" dirty="0"/>
-          </a:p>
-        </p:txBody>
-      </p:sp>
-      <p:sp>
-        <p:nvSpPr>
-          <p:cNvPr id="11" name="Text 9"/>
-          <p:cNvSpPr/>
-          <p:nvPr/>
-        </p:nvSpPr>
-        <p:spPr>
-          <a:xfrm>
-            <a:off x="9144000" y="2971800"/>
-            <a:ext cx="2194560" cy="274320"/>
-          </a:xfrm>
-          <a:prstGeom prst="rect">
-            <a:avLst/>
-          </a:prstGeom>
-          <a:noFill/>
-          <a:ln/>
-        </p:spPr>
-        <p:txBody>
-          <a:bodyPr wrap="square" lIns="0" tIns="0" rIns="0" bIns="0" rtlCol="0" anchor="ctr"/>
-          <a:lstStyle/>
-          <a:p>
-            <a:pPr algn="r" indent="0" marL="0">
-              <a:buNone/>
-            </a:pPr>
-            <a:r>
-              <a:rPr lang="en-US" sz="1000" dirty="0">
-                <a:solidFill>
-                  <a:srgbClr val="97999B"/>
-                </a:solidFill>
-                <a:latin typeface="Courier New" pitchFamily="34" charset="0"/>
-                <a:ea typeface="Courier New" pitchFamily="34" charset="-122"/>
-                <a:cs typeface="Courier New" pitchFamily="34" charset="-120"/>
-              </a:rPr>
-              <a:t>24 h  PBS walltime</a:t>
-            </a:r>
-            <a:endParaRPr lang="en-US" sz="1000" dirty="0"/>
-          </a:p>
-        </p:txBody>
-      </p:sp>
-      <p:sp>
-        <p:nvSpPr>
-          <p:cNvPr id="12" name="Shape 10"/>
-          <p:cNvSpPr/>
-          <p:nvPr/>
-        </p:nvSpPr>
-        <p:spPr>
-          <a:xfrm>
-            <a:off x="822960" y="3246120"/>
-            <a:ext cx="10515600" cy="621792"/>
-          </a:xfrm>
-          <a:prstGeom prst="roundRect">
-            <a:avLst>
-              <a:gd name="adj" fmla="val 10294"/>
             </a:avLst>
           </a:prstGeom>
           <a:solidFill>
@@ -22226,14 +21970,14 @@
       </p:sp>
       <p:sp>
         <p:nvSpPr>
-          <p:cNvPr id="13" name="Text 11"/>
-          <p:cNvSpPr/>
-          <p:nvPr/>
-        </p:nvSpPr>
-        <p:spPr>
-          <a:xfrm>
-            <a:off x="1005840" y="3246120"/>
-            <a:ext cx="2286000" cy="621792"/>
+          <p:cNvPr id="6" name="Text 4"/>
+          <p:cNvSpPr/>
+          <p:nvPr/>
+        </p:nvSpPr>
+        <p:spPr>
+          <a:xfrm>
+            <a:off x="822960" y="2514600"/>
+            <a:ext cx="10515600" cy="384048"/>
           </a:xfrm>
           <a:prstGeom prst="rect">
             <a:avLst/>
@@ -22245,34 +21989,96 @@
           <a:bodyPr wrap="square" lIns="0" tIns="0" rIns="0" bIns="0" rtlCol="0" anchor="ctr"/>
           <a:lstStyle/>
           <a:p>
-            <a:pPr indent="0" marL="0">
-              <a:buNone/>
-            </a:pPr>
-            <a:r>
-              <a:rPr lang="en-US" sz="1250" b="1" dirty="0">
+            <a:pPr algn="ctr" indent="0" marL="0">
+              <a:buNone/>
+            </a:pPr>
+            <a:r>
+              <a:rPr lang="en-US" sz="1200" b="1" dirty="0">
+                <a:solidFill>
+                  <a:srgbClr val="FFFFFF"/>
+                </a:solidFill>
+                <a:latin typeface="Poppins" pitchFamily="34" charset="0"/>
+                <a:ea typeface="Poppins" pitchFamily="34" charset="-122"/>
+                <a:cs typeface="Poppins" pitchFamily="34" charset="-120"/>
+              </a:rPr>
+              <a:t>work continues   —   0 h to the walltime</a:t>
+            </a:r>
+            <a:endParaRPr lang="en-US" sz="1200" dirty="0"/>
+          </a:p>
+        </p:txBody>
+      </p:sp>
+      <p:sp>
+        <p:nvSpPr>
+          <p:cNvPr id="7" name="Shape 5"/>
+          <p:cNvSpPr/>
+          <p:nvPr/>
+        </p:nvSpPr>
+        <p:spPr>
+          <a:xfrm>
+            <a:off x="10900410" y="2404872"/>
+            <a:ext cx="0" cy="603504"/>
+          </a:xfrm>
+          <a:prstGeom prst="line">
+            <a:avLst/>
+          </a:prstGeom>
+          <a:noFill/>
+          <a:ln w="25400">
+            <a:solidFill>
+              <a:srgbClr val="42C0FF"/>
+            </a:solidFill>
+            <a:prstDash val="solid"/>
+          </a:ln>
+        </p:spPr>
+      </p:sp>
+      <p:sp>
+        <p:nvSpPr>
+          <p:cNvPr id="8" name="Text 6"/>
+          <p:cNvSpPr/>
+          <p:nvPr/>
+        </p:nvSpPr>
+        <p:spPr>
+          <a:xfrm>
+            <a:off x="7059930" y="2130552"/>
+            <a:ext cx="3840480" cy="274320"/>
+          </a:xfrm>
+          <a:prstGeom prst="rect">
+            <a:avLst/>
+          </a:prstGeom>
+          <a:noFill/>
+          <a:ln/>
+        </p:spPr>
+        <p:txBody>
+          <a:bodyPr wrap="square" lIns="0" tIns="0" rIns="0" bIns="0" rtlCol="0" anchor="ctr"/>
+          <a:lstStyle/>
+          <a:p>
+            <a:pPr algn="r" indent="0" marL="0">
+              <a:buNone/>
+            </a:pPr>
+            <a:r>
+              <a:rPr lang="en-US" sz="1000" dirty="0">
                 <a:solidFill>
                   <a:srgbClr val="42C0FF"/>
                 </a:solidFill>
-                <a:latin typeface="Poppins" pitchFamily="34" charset="0"/>
-                <a:ea typeface="Poppins" pitchFamily="34" charset="-122"/>
-                <a:cs typeface="Poppins" pitchFamily="34" charset="-120"/>
-              </a:rPr>
-              <a:t>Before each unit</a:t>
-            </a:r>
-            <a:endParaRPr lang="en-US" sz="1250" dirty="0"/>
-          </a:p>
-        </p:txBody>
-      </p:sp>
-      <p:sp>
-        <p:nvSpPr>
-          <p:cNvPr id="14" name="Text 12"/>
-          <p:cNvSpPr/>
-          <p:nvPr/>
-        </p:nvSpPr>
-        <p:spPr>
-          <a:xfrm>
-            <a:off x="3337560" y="3246120"/>
-            <a:ext cx="7818120" cy="621792"/>
+                <a:latin typeface="Courier New" pitchFamily="34" charset="0"/>
+                <a:ea typeface="Courier New" pitchFamily="34" charset="-122"/>
+                <a:cs typeface="Courier New" pitchFamily="34" charset="-120"/>
+              </a:rPr>
+              <a:t>MAXRUNTIME  23 h  —  cache the report</a:t>
+            </a:r>
+            <a:endParaRPr lang="en-US" sz="1000" dirty="0"/>
+          </a:p>
+        </p:txBody>
+      </p:sp>
+      <p:sp>
+        <p:nvSpPr>
+          <p:cNvPr id="9" name="Text 7"/>
+          <p:cNvSpPr/>
+          <p:nvPr/>
+        </p:nvSpPr>
+        <p:spPr>
+          <a:xfrm>
+            <a:off x="822960" y="2971800"/>
+            <a:ext cx="1645920" cy="274320"/>
           </a:xfrm>
           <a:prstGeom prst="rect">
             <a:avLst/>
@@ -22284,36 +22090,72 @@
           <a:bodyPr wrap="square" lIns="0" tIns="0" rIns="0" bIns="0" rtlCol="0" anchor="ctr"/>
           <a:lstStyle/>
           <a:p>
-            <a:pPr indent="0" marL="0">
-              <a:lnSpc>
-                <a:spcPct val="100000"/>
-              </a:lnSpc>
-              <a:buNone/>
-            </a:pPr>
-            <a:r>
-              <a:rPr lang="en-US" sz="1100" dirty="0">
-                <a:solidFill>
-                  <a:srgbClr val="C3D7EE"/>
-                </a:solidFill>
-                <a:latin typeface="Poppins" pitchFamily="34" charset="0"/>
-                <a:ea typeface="Poppins" pitchFamily="34" charset="-122"/>
-                <a:cs typeface="Poppins" pitchFamily="34" charset="-120"/>
-              </a:rPr>
-              <a:t>The remaining time is compared against what the next tar file or transfer batch is expected to need.</a:t>
-            </a:r>
-            <a:endParaRPr lang="en-US" sz="1100" dirty="0"/>
-          </a:p>
-        </p:txBody>
-      </p:sp>
-      <p:sp>
-        <p:nvSpPr>
-          <p:cNvPr id="15" name="Shape 13"/>
-          <p:cNvSpPr/>
-          <p:nvPr/>
-        </p:nvSpPr>
-        <p:spPr>
-          <a:xfrm>
-            <a:off x="822960" y="3931920"/>
+            <a:pPr algn="l" indent="0" marL="0">
+              <a:buNone/>
+            </a:pPr>
+            <a:r>
+              <a:rPr lang="en-US" sz="1000" dirty="0">
+                <a:solidFill>
+                  <a:srgbClr val="97999B"/>
+                </a:solidFill>
+                <a:latin typeface="Courier New" pitchFamily="34" charset="0"/>
+                <a:ea typeface="Courier New" pitchFamily="34" charset="-122"/>
+                <a:cs typeface="Courier New" pitchFamily="34" charset="-120"/>
+              </a:rPr>
+              <a:t>0 h</a:t>
+            </a:r>
+            <a:endParaRPr lang="en-US" sz="1000" dirty="0"/>
+          </a:p>
+        </p:txBody>
+      </p:sp>
+      <p:sp>
+        <p:nvSpPr>
+          <p:cNvPr id="10" name="Text 8"/>
+          <p:cNvSpPr/>
+          <p:nvPr/>
+        </p:nvSpPr>
+        <p:spPr>
+          <a:xfrm>
+            <a:off x="9144000" y="2971800"/>
+            <a:ext cx="2194560" cy="274320"/>
+          </a:xfrm>
+          <a:prstGeom prst="rect">
+            <a:avLst/>
+          </a:prstGeom>
+          <a:noFill/>
+          <a:ln/>
+        </p:spPr>
+        <p:txBody>
+          <a:bodyPr wrap="square" lIns="0" tIns="0" rIns="0" bIns="0" rtlCol="0" anchor="ctr"/>
+          <a:lstStyle/>
+          <a:p>
+            <a:pPr algn="r" indent="0" marL="0">
+              <a:buNone/>
+            </a:pPr>
+            <a:r>
+              <a:rPr lang="en-US" sz="1000" dirty="0">
+                <a:solidFill>
+                  <a:srgbClr val="97999B"/>
+                </a:solidFill>
+                <a:latin typeface="Courier New" pitchFamily="34" charset="0"/>
+                <a:ea typeface="Courier New" pitchFamily="34" charset="-122"/>
+                <a:cs typeface="Courier New" pitchFamily="34" charset="-120"/>
+              </a:rPr>
+              <a:t>24 h  PBS walltime</a:t>
+            </a:r>
+            <a:endParaRPr lang="en-US" sz="1000" dirty="0"/>
+          </a:p>
+        </p:txBody>
+      </p:sp>
+      <p:sp>
+        <p:nvSpPr>
+          <p:cNvPr id="11" name="Shape 9"/>
+          <p:cNvSpPr/>
+          <p:nvPr/>
+        </p:nvSpPr>
+        <p:spPr>
+          <a:xfrm>
+            <a:off x="822960" y="3246120"/>
             <a:ext cx="10515600" cy="621792"/>
           </a:xfrm>
           <a:prstGeom prst="roundRect">
@@ -22334,13 +22176,13 @@
       </p:sp>
       <p:sp>
         <p:nvSpPr>
-          <p:cNvPr id="16" name="Text 14"/>
-          <p:cNvSpPr/>
-          <p:nvPr/>
-        </p:nvSpPr>
-        <p:spPr>
-          <a:xfrm>
-            <a:off x="1005840" y="3931920"/>
+          <p:cNvPr id="12" name="Text 10"/>
+          <p:cNvSpPr/>
+          <p:nvPr/>
+        </p:nvSpPr>
+        <p:spPr>
+          <a:xfrm>
+            <a:off x="1005840" y="3246120"/>
             <a:ext cx="2286000" cy="621792"/>
           </a:xfrm>
           <a:prstGeom prst="rect">
@@ -22365,7 +22207,7 @@
                 <a:ea typeface="Poppins" pitchFamily="34" charset="-122"/>
                 <a:cs typeface="Poppins" pitchFamily="34" charset="-120"/>
               </a:rPr>
-              <a:t>Past 23 hours</a:t>
+              <a:t>Ask PBS, not the clock</a:t>
             </a:r>
             <a:endParaRPr lang="en-US" sz="1250" dirty="0"/>
           </a:p>
@@ -22373,13 +22215,13 @@
       </p:sp>
       <p:sp>
         <p:nvSpPr>
-          <p:cNvPr id="17" name="Text 15"/>
-          <p:cNvSpPr/>
-          <p:nvPr/>
-        </p:nvSpPr>
-        <p:spPr>
-          <a:xfrm>
-            <a:off x="3337560" y="3931920"/>
+          <p:cNvPr id="13" name="Text 11"/>
+          <p:cNvSpPr/>
+          <p:nvPr/>
+        </p:nvSpPr>
+        <p:spPr>
+          <a:xfrm>
+            <a:off x="3337560" y="3246120"/>
             <a:ext cx="7818120" cy="621792"/>
           </a:xfrm>
           <a:prstGeom prst="rect">
@@ -22407,7 +22249,7 @@
                 <a:ea typeface="Poppins" pitchFamily="34" charset="-122"/>
                 <a:cs typeface="Poppins" pitchFamily="34" charset="-120"/>
               </a:rPr>
-              <a:t>No new unit is started. Children already running are waited on so nothing is truncated.</a:t>
+              <a:t>qstat gives back the walltime actually granted — the daemon can cap the 24 hours asked for to the queue maximum. The cutoff is always one hour short of it.</a:t>
             </a:r>
             <a:endParaRPr lang="en-US" sz="1100" dirty="0"/>
           </a:p>
@@ -22415,13 +22257,13 @@
       </p:sp>
       <p:sp>
         <p:nvSpPr>
-          <p:cNvPr id="18" name="Shape 16"/>
-          <p:cNvSpPr/>
-          <p:nvPr/>
-        </p:nvSpPr>
-        <p:spPr>
-          <a:xfrm>
-            <a:off x="822960" y="4617720"/>
+          <p:cNvPr id="14" name="Shape 12"/>
+          <p:cNvSpPr/>
+          <p:nvPr/>
+        </p:nvSpPr>
+        <p:spPr>
+          <a:xfrm>
+            <a:off x="822960" y="3931920"/>
             <a:ext cx="10515600" cy="621792"/>
           </a:xfrm>
           <a:prstGeom prst="roundRect">
@@ -22442,13 +22284,13 @@
       </p:sp>
       <p:sp>
         <p:nvSpPr>
-          <p:cNvPr id="19" name="Text 17"/>
-          <p:cNvSpPr/>
-          <p:nvPr/>
-        </p:nvSpPr>
-        <p:spPr>
-          <a:xfrm>
-            <a:off x="1005840" y="4617720"/>
+          <p:cNvPr id="15" name="Text 13"/>
+          <p:cNvSpPr/>
+          <p:nvPr/>
+        </p:nvSpPr>
+        <p:spPr>
+          <a:xfrm>
+            <a:off x="1005840" y="3931920"/>
             <a:ext cx="2286000" cy="621792"/>
           </a:xfrm>
           <a:prstGeom prst="rect">
@@ -22473,7 +22315,7 @@
                 <a:ea typeface="Poppins" pitchFamily="34" charset="-122"/>
                 <a:cs typeface="Poppins" pitchFamily="34" charset="-120"/>
               </a:rPr>
-              <a:t>Progress email</a:t>
+              <a:t>At the cutoff</a:t>
             </a:r>
             <a:endParaRPr lang="en-US" sz="1250" dirty="0"/>
           </a:p>
@@ -22481,13 +22323,13 @@
       </p:sp>
       <p:sp>
         <p:nvSpPr>
-          <p:cNvPr id="20" name="Text 18"/>
-          <p:cNvSpPr/>
-          <p:nvPr/>
-        </p:nvSpPr>
-        <p:spPr>
-          <a:xfrm>
-            <a:off x="3337560" y="4617720"/>
+          <p:cNvPr id="16" name="Text 14"/>
+          <p:cNvSpPr/>
+          <p:nvPr/>
+        </p:nvSpPr>
+        <p:spPr>
+          <a:xfrm>
+            <a:off x="3337560" y="3931920"/>
             <a:ext cx="7818120" cy="621792"/>
           </a:xfrm>
           <a:prstGeom prst="rect">
@@ -22515,7 +22357,7 @@
                 <a:ea typeface="Poppins" pitchFamily="34" charset="-122"/>
                 <a:cs typeface="Poppins" pitchFamily="34" charset="-120"/>
               </a:rPr>
-              <a:t>The specialist is mailed what finished and what is still outstanding, so the next run is not a surprise.</a:t>
+              <a:t>A progress report is written straight into dscheck.einfo, naming the elapsed time and the tar files left to build and to transfer. The run does not stop.</a:t>
             </a:r>
             <a:endParaRPr lang="en-US" sz="1100" dirty="0"/>
           </a:p>
@@ -22523,13 +22365,13 @@
       </p:sp>
       <p:sp>
         <p:nvSpPr>
-          <p:cNvPr id="21" name="Shape 19"/>
-          <p:cNvSpPr/>
-          <p:nvPr/>
-        </p:nvSpPr>
-        <p:spPr>
-          <a:xfrm>
-            <a:off x="822960" y="5303520"/>
+          <p:cNvPr id="17" name="Shape 15"/>
+          <p:cNvSpPr/>
+          <p:nvPr/>
+        </p:nvSpPr>
+        <p:spPr>
+          <a:xfrm>
+            <a:off x="822960" y="4617720"/>
             <a:ext cx="10515600" cy="621792"/>
           </a:xfrm>
           <a:prstGeom prst="roundRect">
@@ -22550,13 +22392,13 @@
       </p:sp>
       <p:sp>
         <p:nvSpPr>
-          <p:cNvPr id="22" name="Text 20"/>
-          <p:cNvSpPr/>
-          <p:nvPr/>
-        </p:nvSpPr>
-        <p:spPr>
-          <a:xfrm>
-            <a:off x="1005840" y="5303520"/>
+          <p:cNvPr id="18" name="Text 16"/>
+          <p:cNvSpPr/>
+          <p:nvPr/>
+        </p:nvSpPr>
+        <p:spPr>
+          <a:xfrm>
+            <a:off x="1005840" y="4617720"/>
             <a:ext cx="2286000" cy="621792"/>
           </a:xfrm>
           <a:prstGeom prst="rect">
@@ -22581,7 +22423,7 @@
                 <a:ea typeface="Poppins" pitchFamily="34" charset="-122"/>
                 <a:cs typeface="Poppins" pitchFamily="34" charset="-120"/>
               </a:rPr>
-              <a:t>Record kept open</a:t>
+              <a:t>If PBS kills the job</a:t>
             </a:r>
             <a:endParaRPr lang="en-US" sz="1250" dirty="0"/>
           </a:p>
@@ -22589,13 +22431,13 @@
       </p:sp>
       <p:sp>
         <p:nvSpPr>
-          <p:cNvPr id="23" name="Text 21"/>
-          <p:cNvSpPr/>
-          <p:nvPr/>
-        </p:nvSpPr>
-        <p:spPr>
-          <a:xfrm>
-            <a:off x="3337560" y="5303520"/>
+          <p:cNvPr id="19" name="Text 17"/>
+          <p:cNvSpPr/>
+          <p:nvPr/>
+        </p:nvSpPr>
+        <p:spPr>
+          <a:xfrm>
+            <a:off x="3337560" y="4617720"/>
             <a:ext cx="7818120" cy="621792"/>
           </a:xfrm>
           <a:prstGeom prst="rect">
@@ -22623,7 +22465,7 @@
                 <a:ea typeface="Poppins" pitchFamily="34" charset="-122"/>
                 <a:cs typeface="Poppins" pitchFamily="34" charset="-120"/>
               </a:rPr>
-              <a:t>Untarred bfile records stay at 'N' and untransferred ones at 'T'. The next scheduled run simply resumes.</a:t>
+              <a:t>The daemon unlocks the dead record, finds einfo filled in, mails it and clears it. An overrun is reported instead of silent.</a:t>
             </a:r>
             <a:endParaRPr lang="en-US" sz="1100" dirty="0"/>
           </a:p>
@@ -22631,7 +22473,115 @@
       </p:sp>
       <p:sp>
         <p:nvSpPr>
-          <p:cNvPr id="24" name="Text 22"/>
+          <p:cNvPr id="20" name="Shape 18"/>
+          <p:cNvSpPr/>
+          <p:nvPr/>
+        </p:nvSpPr>
+        <p:spPr>
+          <a:xfrm>
+            <a:off x="822960" y="5303520"/>
+            <a:ext cx="10515600" cy="621792"/>
+          </a:xfrm>
+          <a:prstGeom prst="roundRect">
+            <a:avLst>
+              <a:gd name="adj" fmla="val 10294"/>
+            </a:avLst>
+          </a:prstGeom>
+          <a:solidFill>
+            <a:srgbClr val="0B2A63"/>
+          </a:solidFill>
+          <a:ln w="12700">
+            <a:solidFill>
+              <a:srgbClr val="2C4E7D"/>
+            </a:solidFill>
+            <a:prstDash val="solid"/>
+          </a:ln>
+        </p:spPr>
+      </p:sp>
+      <p:sp>
+        <p:nvSpPr>
+          <p:cNvPr id="21" name="Text 19"/>
+          <p:cNvSpPr/>
+          <p:nvPr/>
+        </p:nvSpPr>
+        <p:spPr>
+          <a:xfrm>
+            <a:off x="1005840" y="5303520"/>
+            <a:ext cx="2286000" cy="621792"/>
+          </a:xfrm>
+          <a:prstGeom prst="rect">
+            <a:avLst/>
+          </a:prstGeom>
+          <a:noFill/>
+          <a:ln/>
+        </p:spPr>
+        <p:txBody>
+          <a:bodyPr wrap="square" lIns="0" tIns="0" rIns="0" bIns="0" rtlCol="0" anchor="ctr"/>
+          <a:lstStyle/>
+          <a:p>
+            <a:pPr indent="0" marL="0">
+              <a:buNone/>
+            </a:pPr>
+            <a:r>
+              <a:rPr lang="en-US" sz="1250" b="1" dirty="0">
+                <a:solidFill>
+                  <a:srgbClr val="42C0FF"/>
+                </a:solidFill>
+                <a:latin typeface="Poppins" pitchFamily="34" charset="0"/>
+                <a:ea typeface="Poppins" pitchFamily="34" charset="-122"/>
+                <a:cs typeface="Poppins" pitchFamily="34" charset="-120"/>
+              </a:rPr>
+              <a:t>If the run finishes</a:t>
+            </a:r>
+            <a:endParaRPr lang="en-US" sz="1250" dirty="0"/>
+          </a:p>
+        </p:txBody>
+      </p:sp>
+      <p:sp>
+        <p:nvSpPr>
+          <p:cNvPr id="22" name="Text 20"/>
+          <p:cNvSpPr/>
+          <p:nvPr/>
+        </p:nvSpPr>
+        <p:spPr>
+          <a:xfrm>
+            <a:off x="3337560" y="5303520"/>
+            <a:ext cx="7818120" cy="621792"/>
+          </a:xfrm>
+          <a:prstGeom prst="rect">
+            <a:avLst/>
+          </a:prstGeom>
+          <a:noFill/>
+          <a:ln/>
+        </p:spPr>
+        <p:txBody>
+          <a:bodyPr wrap="square" lIns="0" tIns="0" rIns="0" bIns="0" rtlCol="0" anchor="ctr"/>
+          <a:lstStyle/>
+          <a:p>
+            <a:pPr indent="0" marL="0">
+              <a:lnSpc>
+                <a:spcPct val="100000"/>
+              </a:lnSpc>
+              <a:buNone/>
+            </a:pPr>
+            <a:r>
+              <a:rPr lang="en-US" sz="1100" dirty="0">
+                <a:solidFill>
+                  <a:srgbClr val="C3D7EE"/>
+                </a:solidFill>
+                <a:latin typeface="Poppins" pitchFamily="34" charset="0"/>
+                <a:ea typeface="Poppins" pitchFamily="34" charset="-122"/>
+                <a:cs typeface="Poppins" pitchFamily="34" charset="-120"/>
+              </a:rPr>
+              <a:t>The full report overwrites the cached one in einfo, so exactly one mail goes out — the complete one.</a:t>
+            </a:r>
+            <a:endParaRPr lang="en-US" sz="1100" dirty="0"/>
+          </a:p>
+        </p:txBody>
+      </p:sp>
+      <p:sp>
+        <p:nvSpPr>
+          <p:cNvPr id="23" name="Text 21"/>
           <p:cNvSpPr/>
           <p:nvPr/>
         </p:nvSpPr>
@@ -22662,7 +22612,7 @@
                 <a:ea typeface="Poppins" pitchFamily="34" charset="-122"/>
                 <a:cs typeface="Poppins" pitchFamily="34" charset="-120"/>
               </a:rPr>
-              <a:t>The guard only runs inside a real batch job; a foreground run is left to the operator.</a:t>
+              <a:t>The guard only runs inside a real batch job under dscheck with -e; a foreground run mails its report directly.</a:t>
             </a:r>
             <a:endParaRPr lang="en-US" sz="1100" dirty="0"/>
           </a:p>
@@ -22670,7 +22620,7 @@
       </p:sp>
       <p:sp>
         <p:nvSpPr>
-          <p:cNvPr id="25" name="Text 23"/>
+          <p:cNvPr id="24" name="Text 22"/>
           <p:cNvSpPr/>
           <p:nvPr/>
         </p:nvSpPr>
@@ -22709,7 +22659,7 @@
       </p:sp>
       <p:sp>
         <p:nvSpPr>
-          <p:cNvPr id="26" name="Text 24"/>
+          <p:cNvPr id="25" name="Text 23"/>
           <p:cNvSpPr/>
           <p:nvPr/>
         </p:nvSpPr>
@@ -26091,7 +26041,7 @@
                 <a:ea typeface="Poppins" pitchFamily="34" charset="-122"/>
                 <a:cs typeface="Poppins" pitchFamily="34" charset="-120"/>
               </a:rPr>
-              <a:t>The walltime guard mails too.  </a:t>
+              <a:t>A run that overruns still mails.  </a:t>
             </a:r>
             <a:pPr indent="0" marL="0">
               <a:buNone/>
@@ -26105,7 +26055,7 @@
                 <a:ea typeface="Poppins" pitchFamily="34" charset="-122"/>
                 <a:cs typeface="Poppins" pitchFamily="34" charset="-120"/>
               </a:rPr>
-              <a:t>A batch job that stops at 23 hours sends a progress note listing what finished and what is left, so an incomplete run is visible rather than silent.</a:t>
+              <a:t>An hour before the PBS walltime the report so far is cached in dscheck.einfo, so even a job killed by the queue is reported rather than silent.</a:t>
             </a:r>
             <a:endParaRPr lang="en-US" sz="1150" dirty="0"/>
           </a:p>

</xml_diff>

<commit_message>
show the new worker rule on the Worker Slots slide
Slide 22 described the old stall test (6 hours, 1% done). It now lists the
three conditions worker_progress_stalled() checks since 3.0.23: run longer than
2 hours, some work recorded, and a rate that cannot finish 90% of the recorded
work within the walltime.

Co-Authored-By: Claude Opus 5.5 <noreply@anthropic.com>
</commit_message>
<xml_diff>
--- a/docs/slides/dsquasar_guide.pptx
+++ b/docs/slides/dsquasar_guide.pptx
@@ -22835,7 +22835,7 @@
                 <a:ea typeface="Poppins" pitchFamily="34" charset="-122"/>
                 <a:cs typeface="Poppins" pitchFamily="34" charset="-120"/>
               </a:rPr>
-              <a:t>The -A 3 gather runs from cron several times a day, so a crashed job restarts quickly — dead locks are taken over and dscheck retries. The gap was a job that is alive but making no progress: it holds the duplicate key and every later cron line simply blocks.</a:t>
+              <a:t>The -A 3 gather runs from cron several times a day, so a crashed job restarts quickly — dead locks are taken over and dscheck retries. The gap was a job that is alive but too slow to finish: it holds the duplicate key and every later cron line simply blocks.</a:t>
             </a:r>
             <a:endParaRPr lang="en-US" sz="1400" dirty="0"/>
           </a:p>
@@ -22913,7 +22913,7 @@
                 <a:ea typeface="Poppins" pitchFamily="34" charset="-122"/>
                 <a:cs typeface="Poppins" pitchFamily="34" charset="-120"/>
               </a:rPr>
-              <a:t>A repeat submit inspects the running job. Both conditions must hold:</a:t>
+              <a:t>A repeat submit inspects the running job. All three must hold:</a:t>
             </a:r>
             <a:endParaRPr lang="en-US" sz="1150" dirty="0"/>
           </a:p>
@@ -22928,11 +22928,11 @@
         <p:spPr>
           <a:xfrm>
             <a:off x="457200" y="2788920"/>
-            <a:ext cx="5532120" cy="731520"/>
+            <a:ext cx="5532120" cy="960120"/>
           </a:xfrm>
           <a:prstGeom prst="roundRect">
             <a:avLst>
-              <a:gd name="adj" fmla="val 6250"/>
+              <a:gd name="adj" fmla="val 4762"/>
             </a:avLst>
           </a:prstGeom>
           <a:solidFill>
@@ -22950,7 +22950,7 @@
         <p:spPr>
           <a:xfrm>
             <a:off x="585216" y="2788920"/>
-            <a:ext cx="5276088" cy="731520"/>
+            <a:ext cx="5276088" cy="960120"/>
           </a:xfrm>
           <a:prstGeom prst="rect">
             <a:avLst/>
@@ -22977,7 +22977,7 @@
                 <a:ea typeface="Courier New" pitchFamily="34" charset="-122"/>
                 <a:cs typeface="Courier New" pitchFamily="34" charset="-120"/>
               </a:rPr>
-              <a:t>runtime  &gt;  WORKGRACE  (6 hours)</a:t>
+              <a:t>runtime  &gt;  WORKGRACE  (2 hours)</a:t>
             </a:r>
             <a:endParaRPr lang="en-US" sz="1200" dirty="0"/>
           </a:p>
@@ -22997,10 +22997,30 @@
                 <a:ea typeface="Courier New" pitchFamily="34" charset="-122"/>
                 <a:cs typeface="Courier New" pitchFamily="34" charset="-120"/>
               </a:rPr>
-              <a:t>dcount / fcount  &lt;=  MINWDONE  (1 %)</a:t>
+              <a:t>dcount   &gt;  0  (gather finished)</a:t>
             </a:r>
             <a:endParaRPr lang="en-US" sz="1200" dirty="0"/>
           </a:p>
+          <a:p>
+            <a:pPr indent="0" marL="0">
+              <a:lnSpc>
+                <a:spcPct val="100000"/>
+              </a:lnSpc>
+              <a:buNone/>
+            </a:pPr>
+            <a:r>
+              <a:rPr lang="en-US" sz="1200" dirty="0">
+                <a:solidFill>
+                  <a:srgbClr val="0097A7"/>
+                </a:solidFill>
+                <a:latin typeface="Courier New" pitchFamily="34" charset="0"/>
+                <a:ea typeface="Courier New" pitchFamily="34" charset="-122"/>
+                <a:cs typeface="Courier New" pitchFamily="34" charset="-120"/>
+              </a:rPr>
+              <a:t>done rate x walltime  &lt;  MINWPROJ  (90 %)</a:t>
+            </a:r>
+            <a:endParaRPr lang="en-US" sz="1200" dirty="0"/>
+          </a:p>
         </p:txBody>
       </p:sp>
       <p:sp>
@@ -23011,8 +23031,8 @@
         </p:nvSpPr>
         <p:spPr>
           <a:xfrm>
-            <a:off x="457200" y="3657600"/>
-            <a:ext cx="5532120" cy="594360"/>
+            <a:off x="457200" y="3840480"/>
+            <a:ext cx="5532120" cy="566928"/>
           </a:xfrm>
           <a:prstGeom prst="rect">
             <a:avLst/>
@@ -23039,7 +23059,7 @@
                 <a:ea typeface="Poppins" pitchFamily="34" charset="-122"/>
                 <a:cs typeface="Poppins" pitchFamily="34" charset="-120"/>
               </a:rPr>
-              <a:t>Six hours in with under one percent of its recorded work done, the job is treated as stalled and an extra worker is submitted alongside it — up to -W MaxWorkers, default 2.</a:t>
+              <a:t>A job that cannot finish its recorded work this attempt is treated as stalled, and the next cron submit adds an extra worker alongside it — up to -W MaxWorkers, default 2.</a:t>
             </a:r>
             <a:endParaRPr lang="en-US" sz="1150" dirty="0"/>
           </a:p>
@@ -23053,12 +23073,12 @@
         </p:nvSpPr>
         <p:spPr>
           <a:xfrm>
-            <a:off x="457200" y="4343400"/>
-            <a:ext cx="5532120" cy="457200"/>
+            <a:off x="457200" y="4480560"/>
+            <a:ext cx="5532120" cy="411480"/>
           </a:xfrm>
           <a:prstGeom prst="roundRect">
             <a:avLst>
-              <a:gd name="adj" fmla="val 10000"/>
+              <a:gd name="adj" fmla="val 11111"/>
             </a:avLst>
           </a:prstGeom>
           <a:solidFill>
@@ -23075,8 +23095,8 @@
         </p:nvSpPr>
         <p:spPr>
           <a:xfrm>
-            <a:off x="585216" y="4343400"/>
-            <a:ext cx="5276088" cy="457200"/>
+            <a:off x="585216" y="4480560"/>
+            <a:ext cx="5276088" cy="411480"/>
           </a:xfrm>
           <a:prstGeom prst="rect">
             <a:avLst/>
@@ -23117,12 +23137,12 @@
         </p:nvSpPr>
         <p:spPr>
           <a:xfrm>
-            <a:off x="457200" y="4956048"/>
-            <a:ext cx="5532120" cy="1051560"/>
+            <a:off x="457200" y="5029200"/>
+            <a:ext cx="5532120" cy="978408"/>
           </a:xfrm>
           <a:prstGeom prst="roundRect">
             <a:avLst>
-              <a:gd name="adj" fmla="val 6957"/>
+              <a:gd name="adj" fmla="val 7477"/>
             </a:avLst>
           </a:prstGeom>
           <a:solidFill>
@@ -23144,8 +23164,8 @@
         </p:nvSpPr>
         <p:spPr>
           <a:xfrm>
-            <a:off x="640080" y="4956048"/>
-            <a:ext cx="5166360" cy="1051560"/>
+            <a:off x="640080" y="5029200"/>
+            <a:ext cx="5166360" cy="978408"/>
           </a:xfrm>
           <a:prstGeom prst="rect">
             <a:avLst/>

</xml_diff>

<commit_message>
show the Boreas tar process sizing and storage-first worker order in the deck
Co-Authored-By: Claude Opus 5.5 <noreply@anthropic.com>
</commit_message>
<xml_diff>
--- a/docs/slides/dsquasar_guide.pptx
+++ b/docs/slides/dsquasar_guide.pptx
@@ -21214,12 +21214,12 @@
         </p:nvSpPr>
         <p:spPr>
           <a:xfrm>
-            <a:off x="685800" y="2926080"/>
-            <a:ext cx="5120640" cy="685800"/>
+            <a:off x="685800" y="2907792"/>
+            <a:ext cx="5120640" cy="987552"/>
           </a:xfrm>
           <a:prstGeom prst="roundRect">
             <a:avLst>
-              <a:gd name="adj" fmla="val 6667"/>
+              <a:gd name="adj" fmla="val 4630"/>
             </a:avLst>
           </a:prstGeom>
           <a:solidFill>
@@ -21236,8 +21236,8 @@
         </p:nvSpPr>
         <p:spPr>
           <a:xfrm>
-            <a:off x="813816" y="2926080"/>
-            <a:ext cx="4864608" cy="685800"/>
+            <a:off x="813816" y="2907792"/>
+            <a:ext cx="4864608" cy="987552"/>
           </a:xfrm>
           <a:prstGeom prst="rect">
             <a:avLst/>
@@ -21256,7 +21256,7 @@
               <a:buNone/>
             </a:pPr>
             <a:r>
-              <a:rPr lang="en-US" sz="1150" dirty="0">
+              <a:rPr lang="en-US" sz="1100" dirty="0">
                 <a:solidFill>
                   <a:srgbClr val="0097A7"/>
                 </a:solidFill>
@@ -21264,9 +21264,9 @@
                 <a:ea typeface="Courier New" pitchFamily="34" charset="-122"/>
                 <a:cs typeface="Courier New" pitchFamily="34" charset="-120"/>
               </a:rPr>
-              <a:t>MPTLIMIT = 200   tar files per process</a:t>
-            </a:r>
-            <a:endParaRPr lang="en-US" sz="1150" dirty="0"/>
+              <a:t>MPTLIMIT = 200   Glade tar files per process</a:t>
+            </a:r>
+            <a:endParaRPr lang="en-US" sz="1100" dirty="0"/>
           </a:p>
           <a:p>
             <a:pPr indent="0" marL="0">
@@ -21276,7 +21276,7 @@
               <a:buNone/>
             </a:pPr>
             <a:r>
-              <a:rPr lang="en-US" sz="1150" dirty="0">
+              <a:rPr lang="en-US" sz="1100" dirty="0">
                 <a:solidFill>
                   <a:srgbClr val="0097A7"/>
                 </a:solidFill>
@@ -21284,9 +21284,49 @@
                 <a:ea typeface="Courier New" pitchFamily="34" charset="-122"/>
                 <a:cs typeface="Courier New" pitchFamily="34" charset="-120"/>
               </a:rPr>
+              <a:t>MPOLIMIT =  20   Boreas tar files per process</a:t>
+            </a:r>
+            <a:endParaRPr lang="en-US" sz="1100" dirty="0"/>
+          </a:p>
+          <a:p>
+            <a:pPr indent="0" marL="0">
+              <a:lnSpc>
+                <a:spcPct val="100000"/>
+              </a:lnSpc>
+              <a:buNone/>
+            </a:pPr>
+            <a:r>
+              <a:rPr lang="en-US" sz="1100" dirty="0">
+                <a:solidFill>
+                  <a:srgbClr val="0097A7"/>
+                </a:solidFill>
+                <a:latin typeface="Courier New" pitchFamily="34" charset="0"/>
+                <a:ea typeface="Courier New" pitchFamily="34" charset="-122"/>
+                <a:cs typeface="Courier New" pitchFamily="34" charset="-120"/>
+              </a:rPr>
               <a:t>MPTMAX   =  12   process ceiling</a:t>
             </a:r>
-            <a:endParaRPr lang="en-US" sz="1150" dirty="0"/>
+            <a:endParaRPr lang="en-US" sz="1100" dirty="0"/>
+          </a:p>
+          <a:p>
+            <a:pPr indent="0" marL="0">
+              <a:lnSpc>
+                <a:spcPct val="100000"/>
+              </a:lnSpc>
+              <a:buNone/>
+            </a:pPr>
+            <a:r>
+              <a:rPr lang="en-US" sz="1100" dirty="0">
+                <a:solidFill>
+                  <a:srgbClr val="0097A7"/>
+                </a:solidFill>
+                <a:latin typeface="Courier New" pitchFamily="34" charset="0"/>
+                <a:ea typeface="Courier New" pitchFamily="34" charset="-122"/>
+                <a:cs typeface="Courier New" pitchFamily="34" charset="-120"/>
+              </a:rPr>
+              <a:t>procs = ceil(Glade/200 + Boreas/20)</a:t>
+            </a:r>
+            <a:endParaRPr lang="en-US" sz="1100" dirty="0"/>
           </a:p>
         </p:txBody>
       </p:sp>
@@ -21298,8 +21338,8 @@
         </p:nvSpPr>
         <p:spPr>
           <a:xfrm>
-            <a:off x="685800" y="3703320"/>
-            <a:ext cx="5120640" cy="548640"/>
+            <a:off x="685800" y="3968496"/>
+            <a:ext cx="5120640" cy="365760"/>
           </a:xfrm>
           <a:prstGeom prst="rect">
             <a:avLst/>
@@ -21323,7 +21363,7 @@
                 <a:ea typeface="Poppins" pitchFamily="34" charset="-122"/>
                 <a:cs typeface="Poppins" pitchFamily="34" charset="-120"/>
               </a:rPr>
-              <a:t>A small divisor with a high cap: lots of tar work should spread wide.</a:t>
+              <a:t>A small divisor with a high cap: tar work spreads wide, Boreas tars ten times wider.</a:t>
             </a:r>
             <a:endParaRPr lang="en-US" sz="1100" dirty="0"/>
           </a:p>
@@ -21590,7 +21630,7 @@
                 <a:ea typeface="Poppins" pitchFamily="34" charset="-122"/>
                 <a:cs typeface="Poppins" pitchFamily="34" charset="-120"/>
               </a:rPr>
-              <a:t>Why the two sets of numbers</a:t>
+              <a:t>Why Boreas tars get more processes</a:t>
             </a:r>
             <a:endParaRPr lang="en-US" sz="1500" dirty="0"/>
           </a:p>
@@ -21632,7 +21672,7 @@
                 <a:ea typeface="Poppins" pitchFamily="34" charset="-122"/>
                 <a:cs typeface="Poppins" pitchFamily="34" charset="-120"/>
               </a:rPr>
-              <a:t>Both phases once shared a single limit. Tarring came out under-provisioned while uploading reserved cpus it could never use — cpus that PBS charges for and that other jobs then cannot have. Splitting the constants fixed both ends.</a:t>
+              <a:t>Every member of a Boreas tar is staged down from the object store and checksummed before it is tarred, so it takes many times longer than a Glade tar. The backlog sat in one dataset, d694517 (~730 GB, ~146 tars): one process per 200 tars gave it 1, per 20 it gets 8.</a:t>
             </a:r>
             <a:endParaRPr lang="en-US" sz="1200" dirty="0"/>
           </a:p>
@@ -22913,7 +22953,7 @@
                 <a:ea typeface="Poppins" pitchFamily="34" charset="-122"/>
                 <a:cs typeface="Poppins" pitchFamily="34" charset="-120"/>
               </a:rPr>
-              <a:t>A repeat submit inspects the running job. All three must hold:</a:t>
+              <a:t>A repeat submit inspects the running job. Either way counts as stalled:</a:t>
             </a:r>
             <a:endParaRPr lang="en-US" sz="1150" dirty="0"/>
           </a:p>
@@ -22977,7 +23017,7 @@
                 <a:ea typeface="Courier New" pitchFamily="34" charset="-122"/>
                 <a:cs typeface="Courier New" pitchFamily="34" charset="-120"/>
               </a:rPr>
-              <a:t>runtime  &gt;  WORKGRACE  (2 hours)</a:t>
+              <a:t>runtime &gt; WORKGRACE (1 hour) and</a:t>
             </a:r>
             <a:endParaRPr lang="en-US" sz="1200" dirty="0"/>
           </a:p>
@@ -22997,7 +23037,7 @@
                 <a:ea typeface="Courier New" pitchFamily="34" charset="-122"/>
                 <a:cs typeface="Courier New" pitchFamily="34" charset="-120"/>
               </a:rPr>
-              <a:t>dcount   &gt;  0  (gather finished)</a:t>
+              <a:t>   done rate x walltime &lt; MINWPROJ (150 %)</a:t>
             </a:r>
             <a:endParaRPr lang="en-US" sz="1200" dirty="0"/>
           </a:p>
@@ -23017,7 +23057,7 @@
                 <a:ea typeface="Courier New" pitchFamily="34" charset="-122"/>
                 <a:cs typeface="Courier New" pitchFamily="34" charset="-120"/>
               </a:rPr>
-              <a:t>done rate x walltime  &lt;  MINWPROJ  (90 %)</a:t>
+              <a:t>runtime &gt; GATHGRACE (2 hours) and dcount = 0</a:t>
             </a:r>
             <a:endParaRPr lang="en-US" sz="1200" dirty="0"/>
           </a:p>
@@ -23059,7 +23099,7 @@
                 <a:ea typeface="Poppins" pitchFamily="34" charset="-122"/>
                 <a:cs typeface="Poppins" pitchFamily="34" charset="-120"/>
               </a:rPr>
-              <a:t>A job that cannot finish its recorded work this attempt is treated as stalled, and the next cron submit adds an extra worker alongside it — up to -W MaxWorkers, default 2.</a:t>
+              <a:t>A job that is not well on its way to finishing its recorded work this attempt is treated as stalled, and the next cron submit adds an extra worker alongside it — up to -W MaxWorkers, default 2.</a:t>
             </a:r>
             <a:endParaRPr lang="en-US" sz="1150" dirty="0"/>
           </a:p>
@@ -23684,7 +23724,7 @@
                           <a:ea typeface="Poppins" pitchFamily="34" charset="-122"/>
                           <a:cs typeface="Poppins" pitchFamily="34" charset="-120"/>
                         </a:rPr>
-                        <a:t>walks datasets in ascending dsid order</a:t>
+                        <a:t>Boreas datasets first, then Glade; dsid ascending</a:t>
                       </a:r>
                       <a:endParaRPr lang="en-US" sz="1200" dirty="0">
                         <a:latin typeface="Poppins" charset="0"/>
@@ -23822,7 +23862,7 @@
                           <a:ea typeface="Poppins" pitchFamily="34" charset="-122"/>
                           <a:cs typeface="Poppins" pitchFamily="34" charset="-120"/>
                         </a:rPr>
-                        <a:t>walks datasets descending, from d999999</a:t>
+                        <a:t>Glade datasets first, then Boreas; dsid descending</a:t>
                       </a:r>
                       <a:endParaRPr lang="en-US" sz="1200" dirty="0">
                         <a:latin typeface="Poppins" charset="0"/>
@@ -23914,7 +23954,7 @@
                 <a:ea typeface="Poppins" pitchFamily="34" charset="-122"/>
                 <a:cs typeface="Poppins" pitchFamily="34" charset="-120"/>
               </a:rPr>
-              <a:t>A pair of workers therefore meets in the middle rather than fighting over the same dataset lock from the same end of the list.</a:t>
+              <a:t>A pair of workers starts on different storage and meets in the middle rather than fighting over the same dataset lock.</a:t>
             </a:r>
             <a:endParaRPr lang="en-US" sz="1150" dirty="0"/>
           </a:p>
@@ -23978,7 +24018,7 @@
                 <a:ea typeface="Poppins" pitchFamily="34" charset="-122"/>
                 <a:cs typeface="Poppins" pitchFamily="34" charset="-120"/>
               </a:rPr>
-              <a:t>Not a fix for one huge dataset.  </a:t>
+              <a:t>One huge dataset needs more processes.  </a:t>
             </a:r>
             <a:pPr indent="0" marL="0">
               <a:lnSpc>
@@ -23995,7 +24035,7 @@
                 <a:ea typeface="Poppins" pitchFamily="34" charset="-122"/>
                 <a:cs typeface="Poppins" pitchFamily="34" charset="-120"/>
               </a:rPr>
-              <a:t>Locks are per dataset, so a second worker cannot help inside the dataset that is actually stuck.</a:t>
+              <a:t>Locks are per dataset, so a second worker cannot help inside it; more tar processes (MPOLIMIT) do.</a:t>
             </a:r>
             <a:endParaRPr lang="en-US" sz="1100" dirty="0"/>
           </a:p>

</xml_diff>